<commit_message>
Add bibliography slide with full author lists
Adds a dedicated references slide (10/11) covering only the works cited
in the presentation, with complete author lists per source.

Co-Authored-By: Claude Sonnet 4.6 <noreply@anthropic.com>
Claude-Session: https://claude.ai/code/session_01TgkBW6yVRwbaPGv2Zh7FsZ
</commit_message>
<xml_diff>
--- a/Prezentare_Licenta_Gheorghe_Bianca.pptx
+++ b/Prezentare_Licenta_Gheorghe_Bianca.pptx
@@ -15,6 +15,7 @@
     <p:sldId id="263" r:id="rId14"/>
     <p:sldId id="264" r:id="rId15"/>
     <p:sldId id="265" r:id="rId16"/>
+    <p:sldId id="266" r:id="rId17"/>
   </p:sldIdLst>
   <p:sldSz cx="9144000" cy="5143500" type="screen4x3"/>
   <p:notesSz cx="6858000" cy="9144000"/>
@@ -3535,6 +3536,698 @@
         <p:nvPr/>
       </p:nvGrpSpPr>
       <p:grpSpPr/>
+      <p:sp>
+        <p:nvSpPr>
+          <p:cNvPr id="2" name="TextBox 1"/>
+          <p:cNvSpPr txBox="1"/>
+          <p:nvPr/>
+        </p:nvSpPr>
+        <p:spPr>
+          <a:xfrm>
+            <a:off x="502920" y="274320"/>
+            <a:ext cx="8229600" cy="274320"/>
+          </a:xfrm>
+          <a:prstGeom prst="rect">
+            <a:avLst/>
+          </a:prstGeom>
+          <a:noFill/>
+        </p:spPr>
+        <p:txBody>
+          <a:bodyPr wrap="square" anchor="t" lIns="0" rIns="0" tIns="25400" bIns="25400">
+            <a:spAutoFit/>
+          </a:bodyPr>
+          <a:lstStyle/>
+          <a:p>
+            <a:pPr algn="l">
+              <a:lnSpc>
+                <a:spcPct val="100000"/>
+              </a:lnSpc>
+            </a:pPr>
+            <a:r>
+              <a:rPr sz="1200" b="1" i="0">
+                <a:solidFill>
+                  <a:srgbClr val="76F3FB"/>
+                </a:solidFill>
+                <a:latin typeface="Calibri"/>
+              </a:rPr>
+              <a:t>REFERINȚE</a:t>
+            </a:r>
+          </a:p>
+        </p:txBody>
+      </p:sp>
+      <p:sp>
+        <p:nvSpPr>
+          <p:cNvPr id="3" name="TextBox 2"/>
+          <p:cNvSpPr txBox="1"/>
+          <p:nvPr/>
+        </p:nvSpPr>
+        <p:spPr>
+          <a:xfrm>
+            <a:off x="502920" y="502920"/>
+            <a:ext cx="8229600" cy="502920"/>
+          </a:xfrm>
+          <a:prstGeom prst="rect">
+            <a:avLst/>
+          </a:prstGeom>
+          <a:noFill/>
+        </p:spPr>
+        <p:txBody>
+          <a:bodyPr wrap="square" anchor="t" lIns="0" rIns="0" tIns="25400" bIns="25400">
+            <a:spAutoFit/>
+          </a:bodyPr>
+          <a:lstStyle/>
+          <a:p>
+            <a:pPr algn="l">
+              <a:lnSpc>
+                <a:spcPct val="100000"/>
+              </a:lnSpc>
+            </a:pPr>
+            <a:r>
+              <a:rPr sz="2300" b="1" i="0">
+                <a:solidFill>
+                  <a:srgbClr val="FFFFFF"/>
+                </a:solidFill>
+                <a:latin typeface="Calibri"/>
+              </a:rPr>
+              <a:t>Bibliografie</a:t>
+            </a:r>
+          </a:p>
+        </p:txBody>
+      </p:sp>
+      <p:sp>
+        <p:nvSpPr>
+          <p:cNvPr id="4" name="Rectangle 3"/>
+          <p:cNvSpPr/>
+          <p:nvPr/>
+        </p:nvSpPr>
+        <p:spPr>
+          <a:xfrm>
+            <a:off x="521207" y="1033271"/>
+            <a:ext cx="777240" cy="41148"/>
+          </a:xfrm>
+          <a:prstGeom prst="rect">
+            <a:avLst/>
+          </a:prstGeom>
+          <a:solidFill>
+            <a:srgbClr val="76F3FB"/>
+          </a:solidFill>
+          <a:ln>
+            <a:noFill/>
+          </a:ln>
+          <a:effectLst/>
+        </p:spPr>
+        <p:style>
+          <a:lnRef idx="1">
+            <a:schemeClr val="accent1"/>
+          </a:lnRef>
+          <a:fillRef idx="3">
+            <a:schemeClr val="accent1"/>
+          </a:fillRef>
+          <a:effectRef idx="2">
+            <a:schemeClr val="accent1"/>
+          </a:effectRef>
+          <a:fontRef idx="minor">
+            <a:schemeClr val="lt1"/>
+          </a:fontRef>
+        </p:style>
+        <p:txBody>
+          <a:bodyPr rtlCol="0" anchor="ctr"/>
+          <a:lstStyle/>
+          <a:p>
+            <a:pPr algn="ctr"/>
+          </a:p>
+        </p:txBody>
+      </p:sp>
+      <p:sp>
+        <p:nvSpPr>
+          <p:cNvPr id="5" name="TextBox 4"/>
+          <p:cNvSpPr txBox="1"/>
+          <p:nvPr/>
+        </p:nvSpPr>
+        <p:spPr>
+          <a:xfrm>
+            <a:off x="502920" y="4864608"/>
+            <a:ext cx="5486400" cy="228600"/>
+          </a:xfrm>
+          <a:prstGeom prst="rect">
+            <a:avLst/>
+          </a:prstGeom>
+          <a:noFill/>
+        </p:spPr>
+        <p:txBody>
+          <a:bodyPr wrap="square" anchor="t" lIns="0" rIns="0" tIns="25400" bIns="25400">
+            <a:spAutoFit/>
+          </a:bodyPr>
+          <a:lstStyle/>
+          <a:p>
+            <a:pPr algn="l">
+              <a:lnSpc>
+                <a:spcPct val="100000"/>
+              </a:lnSpc>
+            </a:pPr>
+            <a:r>
+              <a:rPr sz="800" b="0" i="1">
+                <a:solidFill>
+                  <a:srgbClr val="A896C4"/>
+                </a:solidFill>
+                <a:latin typeface="Calibri"/>
+              </a:rPr>
+              <a:t>Detectarea mesajelor generate de AI pe rețelele sociale</a:t>
+            </a:r>
+          </a:p>
+        </p:txBody>
+      </p:sp>
+      <p:sp>
+        <p:nvSpPr>
+          <p:cNvPr id="6" name="TextBox 5"/>
+          <p:cNvSpPr txBox="1"/>
+          <p:nvPr/>
+        </p:nvSpPr>
+        <p:spPr>
+          <a:xfrm>
+            <a:off x="8229600" y="4864608"/>
+            <a:ext cx="731520" cy="228600"/>
+          </a:xfrm>
+          <a:prstGeom prst="rect">
+            <a:avLst/>
+          </a:prstGeom>
+          <a:noFill/>
+        </p:spPr>
+        <p:txBody>
+          <a:bodyPr wrap="square" anchor="t" lIns="0" rIns="0" tIns="25400" bIns="25400">
+            <a:spAutoFit/>
+          </a:bodyPr>
+          <a:lstStyle/>
+          <a:p>
+            <a:pPr algn="r">
+              <a:lnSpc>
+                <a:spcPct val="100000"/>
+              </a:lnSpc>
+            </a:pPr>
+            <a:r>
+              <a:rPr sz="900" b="0" i="0">
+                <a:solidFill>
+                  <a:srgbClr val="A896C4"/>
+                </a:solidFill>
+                <a:latin typeface="Calibri"/>
+              </a:rPr>
+              <a:t>10/11</a:t>
+            </a:r>
+          </a:p>
+        </p:txBody>
+      </p:sp>
+      <p:sp>
+        <p:nvSpPr>
+          <p:cNvPr id="7" name="TextBox 6"/>
+          <p:cNvSpPr txBox="1"/>
+          <p:nvPr/>
+        </p:nvSpPr>
+        <p:spPr>
+          <a:xfrm>
+            <a:off x="502920" y="1280160"/>
+            <a:ext cx="4160520" cy="3520440"/>
+          </a:xfrm>
+          <a:prstGeom prst="rect">
+            <a:avLst/>
+          </a:prstGeom>
+          <a:noFill/>
+        </p:spPr>
+        <p:txBody>
+          <a:bodyPr wrap="square" lIns="0" rIns="0" tIns="0">
+            <a:spAutoFit/>
+          </a:bodyPr>
+          <a:lstStyle/>
+          <a:p>
+            <a:pPr>
+              <a:lnSpc>
+                <a:spcPct val="98000"/>
+              </a:lnSpc>
+              <a:spcAft>
+                <a:spcPts val="600"/>
+              </a:spcAft>
+            </a:pPr>
+            <a:r>
+              <a:rPr sz="850">
+                <a:solidFill>
+                  <a:srgbClr val="76F3FB"/>
+                </a:solidFill>
+                <a:latin typeface="Calibri"/>
+              </a:rPr>
+              <a:t>▸ </a:t>
+            </a:r>
+            <a:r>
+              <a:rPr sz="850">
+                <a:solidFill>
+                  <a:srgbClr val="E6DCF5"/>
+                </a:solidFill>
+                <a:latin typeface="Calibri"/>
+              </a:rPr>
+              <a:t>Barbieri, F., Camacho-Collados, J., Espinosa-Anke, L., &amp; Neves, L. (2020). TweetEval: Unified Benchmark and Comparative Evaluation for Tweet Classification. arXiv:2010.12421.</a:t>
+            </a:r>
+          </a:p>
+          <a:p>
+            <a:pPr>
+              <a:lnSpc>
+                <a:spcPct val="98000"/>
+              </a:lnSpc>
+              <a:spcAft>
+                <a:spcPts val="600"/>
+              </a:spcAft>
+            </a:pPr>
+            <a:r>
+              <a:rPr sz="850">
+                <a:solidFill>
+                  <a:srgbClr val="76F3FB"/>
+                </a:solidFill>
+                <a:latin typeface="Calibri"/>
+              </a:rPr>
+              <a:t>▸ </a:t>
+            </a:r>
+            <a:r>
+              <a:rPr sz="850">
+                <a:solidFill>
+                  <a:srgbClr val="E6DCF5"/>
+                </a:solidFill>
+                <a:latin typeface="Calibri"/>
+              </a:rPr>
+              <a:t>Brown, T., Mann, B., Ryder, N., Subbiah, M., Kaplan, J., Dhariwal, P., et al. (2020). Language Models are Few-Shot Learners. arXiv:2005.14165.</a:t>
+            </a:r>
+          </a:p>
+          <a:p>
+            <a:pPr>
+              <a:lnSpc>
+                <a:spcPct val="98000"/>
+              </a:lnSpc>
+              <a:spcAft>
+                <a:spcPts val="600"/>
+              </a:spcAft>
+            </a:pPr>
+            <a:r>
+              <a:rPr sz="850">
+                <a:solidFill>
+                  <a:srgbClr val="76F3FB"/>
+                </a:solidFill>
+                <a:latin typeface="Calibri"/>
+              </a:rPr>
+              <a:t>▸ </a:t>
+            </a:r>
+            <a:r>
+              <a:rPr sz="850">
+                <a:solidFill>
+                  <a:srgbClr val="E6DCF5"/>
+                </a:solidFill>
+                <a:latin typeface="Calibri"/>
+              </a:rPr>
+              <a:t>Chakraborty, S., Bedi, A. S., Zhu, S., An, B., Manocha, D., &amp; Huang, F. (2023). On the Possibilities of AI-Generated Text Detection. arXiv:2304.04736.</a:t>
+            </a:r>
+          </a:p>
+          <a:p>
+            <a:pPr>
+              <a:lnSpc>
+                <a:spcPct val="98000"/>
+              </a:lnSpc>
+              <a:spcAft>
+                <a:spcPts val="600"/>
+              </a:spcAft>
+            </a:pPr>
+            <a:r>
+              <a:rPr sz="850">
+                <a:solidFill>
+                  <a:srgbClr val="76F3FB"/>
+                </a:solidFill>
+                <a:latin typeface="Calibri"/>
+              </a:rPr>
+              <a:t>▸ </a:t>
+            </a:r>
+            <a:r>
+              <a:rPr sz="850">
+                <a:solidFill>
+                  <a:srgbClr val="E6DCF5"/>
+                </a:solidFill>
+                <a:latin typeface="Calibri"/>
+              </a:rPr>
+              <a:t>Dugan, L., Hwang, A., Trhlík, F., Zhu, Z., Ippolito, D., &amp; Callison-Burch, C. (2024). RAID: A Shared Benchmark for Robust Evaluation of Machine-Generated Text Detectors. ACL 2024. arXiv:2405.07940.</a:t>
+            </a:r>
+          </a:p>
+          <a:p>
+            <a:pPr>
+              <a:lnSpc>
+                <a:spcPct val="98000"/>
+              </a:lnSpc>
+              <a:spcAft>
+                <a:spcPts val="600"/>
+              </a:spcAft>
+            </a:pPr>
+            <a:r>
+              <a:rPr sz="850">
+                <a:solidFill>
+                  <a:srgbClr val="76F3FB"/>
+                </a:solidFill>
+                <a:latin typeface="Calibri"/>
+              </a:rPr>
+              <a:t>▸ </a:t>
+            </a:r>
+            <a:r>
+              <a:rPr sz="850">
+                <a:solidFill>
+                  <a:srgbClr val="E6DCF5"/>
+                </a:solidFill>
+                <a:latin typeface="Calibri"/>
+              </a:rPr>
+              <a:t>Gehrmann, S., Strobelt, H., &amp; Rush, A. M. (2019). GLTR: Statistical Detection and Visualization of Generated Text. arXiv:1906.04043.</a:t>
+            </a:r>
+          </a:p>
+          <a:p>
+            <a:pPr>
+              <a:lnSpc>
+                <a:spcPct val="98000"/>
+              </a:lnSpc>
+              <a:spcAft>
+                <a:spcPts val="600"/>
+              </a:spcAft>
+            </a:pPr>
+            <a:r>
+              <a:rPr sz="850">
+                <a:solidFill>
+                  <a:srgbClr val="76F3FB"/>
+                </a:solidFill>
+                <a:latin typeface="Calibri"/>
+              </a:rPr>
+              <a:t>▸ </a:t>
+            </a:r>
+            <a:r>
+              <a:rPr sz="850">
+                <a:solidFill>
+                  <a:srgbClr val="E6DCF5"/>
+                </a:solidFill>
+                <a:latin typeface="Calibri"/>
+              </a:rPr>
+              <a:t>Gillespie, N., Lockey, S., Curtis, C., Pool, J., &amp; Akbari, A. (2025). Trust, Attitudes and Use of Artificial Intelligence: A Global Study 2025. Univ. of Melbourne &amp; KPMG.</a:t>
+            </a:r>
+          </a:p>
+          <a:p>
+            <a:pPr>
+              <a:lnSpc>
+                <a:spcPct val="98000"/>
+              </a:lnSpc>
+              <a:spcAft>
+                <a:spcPts val="600"/>
+              </a:spcAft>
+            </a:pPr>
+            <a:r>
+              <a:rPr sz="850">
+                <a:solidFill>
+                  <a:srgbClr val="76F3FB"/>
+                </a:solidFill>
+                <a:latin typeface="Calibri"/>
+              </a:rPr>
+              <a:t>▸ </a:t>
+            </a:r>
+            <a:r>
+              <a:rPr sz="850">
+                <a:solidFill>
+                  <a:srgbClr val="E6DCF5"/>
+                </a:solidFill>
+                <a:latin typeface="Calibri"/>
+              </a:rPr>
+              <a:t>Guo, W., Shen, W., Lei, J., Chow, K., &amp; Shi, E. (2023). How Close is ChatGPT to Human Experts? Comparison Corpus, Evaluation, and Detection (HC3). arXiv:2301.07597.</a:t>
+            </a:r>
+          </a:p>
+          <a:p>
+            <a:pPr>
+              <a:lnSpc>
+                <a:spcPct val="98000"/>
+              </a:lnSpc>
+              <a:spcAft>
+                <a:spcPts val="600"/>
+              </a:spcAft>
+            </a:pPr>
+            <a:r>
+              <a:rPr sz="850">
+                <a:solidFill>
+                  <a:srgbClr val="76F3FB"/>
+                </a:solidFill>
+                <a:latin typeface="Calibri"/>
+              </a:rPr>
+              <a:t>▸ </a:t>
+            </a:r>
+            <a:r>
+              <a:rPr sz="850">
+                <a:solidFill>
+                  <a:srgbClr val="E6DCF5"/>
+                </a:solidFill>
+                <a:latin typeface="Calibri"/>
+              </a:rPr>
+              <a:t>Kirchenbauer, J., Geiping, J., Wen, Y., Katz, J., Miers, I., &amp; Goldstein, T. (2023). A Watermark for Large Language Models. arXiv:2301.10226.</a:t>
+            </a:r>
+          </a:p>
+        </p:txBody>
+      </p:sp>
+      <p:sp>
+        <p:nvSpPr>
+          <p:cNvPr id="8" name="TextBox 7"/>
+          <p:cNvSpPr txBox="1"/>
+          <p:nvPr/>
+        </p:nvSpPr>
+        <p:spPr>
+          <a:xfrm>
+            <a:off x="4846320" y="1280160"/>
+            <a:ext cx="4160520" cy="3520440"/>
+          </a:xfrm>
+          <a:prstGeom prst="rect">
+            <a:avLst/>
+          </a:prstGeom>
+          <a:noFill/>
+        </p:spPr>
+        <p:txBody>
+          <a:bodyPr wrap="square" lIns="0" rIns="0" tIns="0">
+            <a:spAutoFit/>
+          </a:bodyPr>
+          <a:lstStyle/>
+          <a:p>
+            <a:pPr>
+              <a:lnSpc>
+                <a:spcPct val="98000"/>
+              </a:lnSpc>
+              <a:spcAft>
+                <a:spcPts val="600"/>
+              </a:spcAft>
+            </a:pPr>
+            <a:r>
+              <a:rPr sz="850">
+                <a:solidFill>
+                  <a:srgbClr val="76F3FB"/>
+                </a:solidFill>
+                <a:latin typeface="Calibri"/>
+              </a:rPr>
+              <a:t>▸ </a:t>
+            </a:r>
+            <a:r>
+              <a:rPr sz="850">
+                <a:solidFill>
+                  <a:srgbClr val="E6DCF5"/>
+                </a:solidFill>
+                <a:latin typeface="Calibri"/>
+              </a:rPr>
+              <a:t>Krishna, K., Song, Y., Karpinska, M., Wieting, J., &amp; Iyyer, M. (2023). Paraphrasing Evades Detectors of AI-Generated Text. arXiv:2303.13408.</a:t>
+            </a:r>
+          </a:p>
+          <a:p>
+            <a:pPr>
+              <a:lnSpc>
+                <a:spcPct val="98000"/>
+              </a:lnSpc>
+              <a:spcAft>
+                <a:spcPts val="600"/>
+              </a:spcAft>
+            </a:pPr>
+            <a:r>
+              <a:rPr sz="850">
+                <a:solidFill>
+                  <a:srgbClr val="76F3FB"/>
+                </a:solidFill>
+                <a:latin typeface="Calibri"/>
+              </a:rPr>
+              <a:t>▸ </a:t>
+            </a:r>
+            <a:r>
+              <a:rPr sz="850">
+                <a:solidFill>
+                  <a:srgbClr val="E6DCF5"/>
+                </a:solidFill>
+                <a:latin typeface="Calibri"/>
+              </a:rPr>
+              <a:t>Liu, Y., Ott, M., Goyal, N., Du, J., Joshi, M., Chen, D., et al. (2019). RoBERTa: A Robustly Optimized BERT Pretraining Approach. arXiv:1907.11692.</a:t>
+            </a:r>
+          </a:p>
+          <a:p>
+            <a:pPr>
+              <a:lnSpc>
+                <a:spcPct val="98000"/>
+              </a:lnSpc>
+              <a:spcAft>
+                <a:spcPts val="600"/>
+              </a:spcAft>
+            </a:pPr>
+            <a:r>
+              <a:rPr sz="850">
+                <a:solidFill>
+                  <a:srgbClr val="76F3FB"/>
+                </a:solidFill>
+                <a:latin typeface="Calibri"/>
+              </a:rPr>
+              <a:t>▸ </a:t>
+            </a:r>
+            <a:r>
+              <a:rPr sz="850">
+                <a:solidFill>
+                  <a:srgbClr val="E6DCF5"/>
+                </a:solidFill>
+                <a:latin typeface="Calibri"/>
+              </a:rPr>
+              <a:t>Mitchell, E., Lee, Y., Khazatsky, A., Manning, C. D., &amp; Finn, C. (2023). DetectGPT: Zero-Shot Machine-Generated Text Detection Using Probability Curvature. arXiv:2301.11305.</a:t>
+            </a:r>
+          </a:p>
+          <a:p>
+            <a:pPr>
+              <a:lnSpc>
+                <a:spcPct val="98000"/>
+              </a:lnSpc>
+              <a:spcAft>
+                <a:spcPts val="600"/>
+              </a:spcAft>
+            </a:pPr>
+            <a:r>
+              <a:rPr sz="850">
+                <a:solidFill>
+                  <a:srgbClr val="76F3FB"/>
+                </a:solidFill>
+                <a:latin typeface="Calibri"/>
+              </a:rPr>
+              <a:t>▸ </a:t>
+            </a:r>
+            <a:r>
+              <a:rPr sz="850">
+                <a:solidFill>
+                  <a:srgbClr val="E6DCF5"/>
+                </a:solidFill>
+                <a:latin typeface="Calibri"/>
+              </a:rPr>
+              <a:t>NewsGuard (2023). The Year AI Supercharged Misinformation: NewsGuard's 2023 in Review.</a:t>
+            </a:r>
+          </a:p>
+          <a:p>
+            <a:pPr>
+              <a:lnSpc>
+                <a:spcPct val="98000"/>
+              </a:lnSpc>
+              <a:spcAft>
+                <a:spcPts val="600"/>
+              </a:spcAft>
+            </a:pPr>
+            <a:r>
+              <a:rPr sz="850">
+                <a:solidFill>
+                  <a:srgbClr val="76F3FB"/>
+                </a:solidFill>
+                <a:latin typeface="Calibri"/>
+              </a:rPr>
+              <a:t>▸ </a:t>
+            </a:r>
+            <a:r>
+              <a:rPr sz="850">
+                <a:solidFill>
+                  <a:srgbClr val="E6DCF5"/>
+                </a:solidFill>
+                <a:latin typeface="Calibri"/>
+              </a:rPr>
+              <a:t>Sadasivan, V. S., Kumar, A., Balasubramanian, S., Wang, W., &amp; Feizi, S. (2023). Can AI-Generated Text be Reliably Detected? arXiv:2303.11156.</a:t>
+            </a:r>
+          </a:p>
+          <a:p>
+            <a:pPr>
+              <a:lnSpc>
+                <a:spcPct val="98000"/>
+              </a:lnSpc>
+              <a:spcAft>
+                <a:spcPts val="600"/>
+              </a:spcAft>
+            </a:pPr>
+            <a:r>
+              <a:rPr sz="850">
+                <a:solidFill>
+                  <a:srgbClr val="76F3FB"/>
+                </a:solidFill>
+                <a:latin typeface="Calibri"/>
+              </a:rPr>
+              <a:t>▸ </a:t>
+            </a:r>
+            <a:r>
+              <a:rPr sz="850">
+                <a:solidFill>
+                  <a:srgbClr val="E6DCF5"/>
+                </a:solidFill>
+                <a:latin typeface="Calibri"/>
+              </a:rPr>
+              <a:t>Tian, E. (2023). GPTZero. gptzero.me.</a:t>
+            </a:r>
+          </a:p>
+          <a:p>
+            <a:pPr>
+              <a:lnSpc>
+                <a:spcPct val="98000"/>
+              </a:lnSpc>
+              <a:spcAft>
+                <a:spcPts val="600"/>
+              </a:spcAft>
+            </a:pPr>
+            <a:r>
+              <a:rPr sz="850">
+                <a:solidFill>
+                  <a:srgbClr val="76F3FB"/>
+                </a:solidFill>
+                <a:latin typeface="Calibri"/>
+              </a:rPr>
+              <a:t>▸ </a:t>
+            </a:r>
+            <a:r>
+              <a:rPr sz="850">
+                <a:solidFill>
+                  <a:srgbClr val="E6DCF5"/>
+                </a:solidFill>
+                <a:latin typeface="Calibri"/>
+              </a:rPr>
+              <a:t>Vaswani, A., Shazeer, N., Parmar, N., Uszkoreit, J., Jones, L., Gomez, A. N., et al. (2017). Attention is All You Need. arXiv:1706.03762.</a:t>
+            </a:r>
+          </a:p>
+        </p:txBody>
+      </p:sp>
+    </p:spTree>
+  </p:cSld>
+  <p:clrMapOvr>
+    <a:masterClrMapping/>
+  </p:clrMapOvr>
+</p:sld>
+</file>
+
+<file path=ppt/slides/slide11.xml><?xml version="1.0" encoding="utf-8"?>
+<p:sld xmlns:a="http://schemas.openxmlformats.org/drawingml/2006/main" xmlns:p="http://schemas.openxmlformats.org/presentationml/2006/main" xmlns:r="http://schemas.openxmlformats.org/officeDocument/2006/relationships">
+  <p:cSld>
+    <p:bg>
+      <p:bgPr>
+        <a:solidFill>
+          <a:srgbClr val="27173A"/>
+        </a:solidFill>
+        <a:effectLst/>
+      </p:bgPr>
+    </p:bg>
+    <p:spTree>
+      <p:nvGrpSpPr>
+        <p:cNvPr id="1" name=""/>
+        <p:cNvGrpSpPr/>
+        <p:nvPr/>
+      </p:nvGrpSpPr>
+      <p:grpSpPr/>
       <p:pic>
         <p:nvPicPr>
           <p:cNvPr id="2" name="Picture 1" descr="image4.png"/>
@@ -4394,7 +5087,7 @@
                 </a:solidFill>
                 <a:latin typeface="Calibri"/>
               </a:rPr>
-              <a:t>2/10</a:t>
+              <a:t>2/11</a:t>
             </a:r>
           </a:p>
         </p:txBody>
@@ -5251,7 +5944,7 @@
                 </a:solidFill>
                 <a:latin typeface="Calibri"/>
               </a:rPr>
-              <a:t>3/10</a:t>
+              <a:t>3/11</a:t>
             </a:r>
           </a:p>
         </p:txBody>
@@ -6473,7 +7166,7 @@
                 </a:solidFill>
                 <a:latin typeface="Calibri"/>
               </a:rPr>
-              <a:t>4/10</a:t>
+              <a:t>4/11</a:t>
             </a:r>
           </a:p>
         </p:txBody>
@@ -8001,7 +8694,7 @@
                 </a:solidFill>
                 <a:latin typeface="Calibri"/>
               </a:rPr>
-              <a:t>5/10</a:t>
+              <a:t>5/11</a:t>
             </a:r>
           </a:p>
         </p:txBody>
@@ -9067,7 +9760,7 @@
                 </a:solidFill>
                 <a:latin typeface="Calibri"/>
               </a:rPr>
-              <a:t>6/10</a:t>
+              <a:t>6/11</a:t>
             </a:r>
           </a:p>
         </p:txBody>
@@ -10319,7 +11012,7 @@
                 </a:solidFill>
                 <a:latin typeface="Calibri"/>
               </a:rPr>
-              <a:t>7/10</a:t>
+              <a:t>7/11</a:t>
             </a:r>
           </a:p>
         </p:txBody>
@@ -11773,7 +12466,7 @@
                 </a:solidFill>
                 <a:latin typeface="Calibri"/>
               </a:rPr>
-              <a:t>8/10</a:t>
+              <a:t>8/11</a:t>
             </a:r>
           </a:p>
         </p:txBody>
@@ -13048,7 +13741,7 @@
                 </a:solidFill>
                 <a:latin typeface="Calibri"/>
               </a:rPr>
-              <a:t>9/10</a:t>
+              <a:t>9/11</a:t>
             </a:r>
           </a:p>
         </p:txBody>

</xml_diff>

<commit_message>
Add in-text citation markers linked to numbered bibliography
Numbers the bibliography [1]-[15] and adds matching [n] citation markers
across the content slides (tema, analiza, proiectare, realizare) so each
claim points to its source.

Co-Authored-By: Claude Sonnet 4.6 <noreply@anthropic.com>
Claude-Session: https://claude.ai/code/session_01TgkBW6yVRwbaPGv2Zh7FsZ
</commit_message>
<xml_diff>
--- a/Prezentare_Licenta_Gheorghe_Bianca.pptx
+++ b/Prezentare_Licenta_Gheorghe_Bianca.pptx
@@ -3767,13 +3767,13 @@
               </a:spcAft>
             </a:pPr>
             <a:r>
-              <a:rPr sz="850">
+              <a:rPr sz="850" b="1">
                 <a:solidFill>
                   <a:srgbClr val="76F3FB"/>
                 </a:solidFill>
                 <a:latin typeface="Calibri"/>
               </a:rPr>
-              <a:t>▸ </a:t>
+              <a:t>[1] </a:t>
             </a:r>
             <a:r>
               <a:rPr sz="850">
@@ -3795,13 +3795,13 @@
               </a:spcAft>
             </a:pPr>
             <a:r>
-              <a:rPr sz="850">
+              <a:rPr sz="850" b="1">
                 <a:solidFill>
                   <a:srgbClr val="76F3FB"/>
                 </a:solidFill>
                 <a:latin typeface="Calibri"/>
               </a:rPr>
-              <a:t>▸ </a:t>
+              <a:t>[2] </a:t>
             </a:r>
             <a:r>
               <a:rPr sz="850">
@@ -3823,13 +3823,13 @@
               </a:spcAft>
             </a:pPr>
             <a:r>
-              <a:rPr sz="850">
+              <a:rPr sz="850" b="1">
                 <a:solidFill>
                   <a:srgbClr val="76F3FB"/>
                 </a:solidFill>
                 <a:latin typeface="Calibri"/>
               </a:rPr>
-              <a:t>▸ </a:t>
+              <a:t>[3] </a:t>
             </a:r>
             <a:r>
               <a:rPr sz="850">
@@ -3851,13 +3851,13 @@
               </a:spcAft>
             </a:pPr>
             <a:r>
-              <a:rPr sz="850">
+              <a:rPr sz="850" b="1">
                 <a:solidFill>
                   <a:srgbClr val="76F3FB"/>
                 </a:solidFill>
                 <a:latin typeface="Calibri"/>
               </a:rPr>
-              <a:t>▸ </a:t>
+              <a:t>[4] </a:t>
             </a:r>
             <a:r>
               <a:rPr sz="850">
@@ -3879,13 +3879,13 @@
               </a:spcAft>
             </a:pPr>
             <a:r>
-              <a:rPr sz="850">
+              <a:rPr sz="850" b="1">
                 <a:solidFill>
                   <a:srgbClr val="76F3FB"/>
                 </a:solidFill>
                 <a:latin typeface="Calibri"/>
               </a:rPr>
-              <a:t>▸ </a:t>
+              <a:t>[5] </a:t>
             </a:r>
             <a:r>
               <a:rPr sz="850">
@@ -3907,13 +3907,13 @@
               </a:spcAft>
             </a:pPr>
             <a:r>
-              <a:rPr sz="850">
+              <a:rPr sz="850" b="1">
                 <a:solidFill>
                   <a:srgbClr val="76F3FB"/>
                 </a:solidFill>
                 <a:latin typeface="Calibri"/>
               </a:rPr>
-              <a:t>▸ </a:t>
+              <a:t>[6] </a:t>
             </a:r>
             <a:r>
               <a:rPr sz="850">
@@ -3935,13 +3935,13 @@
               </a:spcAft>
             </a:pPr>
             <a:r>
-              <a:rPr sz="850">
+              <a:rPr sz="850" b="1">
                 <a:solidFill>
                   <a:srgbClr val="76F3FB"/>
                 </a:solidFill>
                 <a:latin typeface="Calibri"/>
               </a:rPr>
-              <a:t>▸ </a:t>
+              <a:t>[7] </a:t>
             </a:r>
             <a:r>
               <a:rPr sz="850">
@@ -3963,13 +3963,13 @@
               </a:spcAft>
             </a:pPr>
             <a:r>
-              <a:rPr sz="850">
+              <a:rPr sz="850" b="1">
                 <a:solidFill>
                   <a:srgbClr val="76F3FB"/>
                 </a:solidFill>
                 <a:latin typeface="Calibri"/>
               </a:rPr>
-              <a:t>▸ </a:t>
+              <a:t>[8] </a:t>
             </a:r>
             <a:r>
               <a:rPr sz="850">
@@ -4014,13 +4014,13 @@
               </a:spcAft>
             </a:pPr>
             <a:r>
-              <a:rPr sz="850">
+              <a:rPr sz="850" b="1">
                 <a:solidFill>
                   <a:srgbClr val="76F3FB"/>
                 </a:solidFill>
                 <a:latin typeface="Calibri"/>
               </a:rPr>
-              <a:t>▸ </a:t>
+              <a:t>[9] </a:t>
             </a:r>
             <a:r>
               <a:rPr sz="850">
@@ -4042,13 +4042,13 @@
               </a:spcAft>
             </a:pPr>
             <a:r>
-              <a:rPr sz="850">
+              <a:rPr sz="850" b="1">
                 <a:solidFill>
                   <a:srgbClr val="76F3FB"/>
                 </a:solidFill>
                 <a:latin typeface="Calibri"/>
               </a:rPr>
-              <a:t>▸ </a:t>
+              <a:t>[10] </a:t>
             </a:r>
             <a:r>
               <a:rPr sz="850">
@@ -4070,13 +4070,13 @@
               </a:spcAft>
             </a:pPr>
             <a:r>
-              <a:rPr sz="850">
+              <a:rPr sz="850" b="1">
                 <a:solidFill>
                   <a:srgbClr val="76F3FB"/>
                 </a:solidFill>
                 <a:latin typeface="Calibri"/>
               </a:rPr>
-              <a:t>▸ </a:t>
+              <a:t>[11] </a:t>
             </a:r>
             <a:r>
               <a:rPr sz="850">
@@ -4098,13 +4098,13 @@
               </a:spcAft>
             </a:pPr>
             <a:r>
-              <a:rPr sz="850">
+              <a:rPr sz="850" b="1">
                 <a:solidFill>
                   <a:srgbClr val="76F3FB"/>
                 </a:solidFill>
                 <a:latin typeface="Calibri"/>
               </a:rPr>
-              <a:t>▸ </a:t>
+              <a:t>[12] </a:t>
             </a:r>
             <a:r>
               <a:rPr sz="850">
@@ -4126,13 +4126,13 @@
               </a:spcAft>
             </a:pPr>
             <a:r>
-              <a:rPr sz="850">
+              <a:rPr sz="850" b="1">
                 <a:solidFill>
                   <a:srgbClr val="76F3FB"/>
                 </a:solidFill>
                 <a:latin typeface="Calibri"/>
               </a:rPr>
-              <a:t>▸ </a:t>
+              <a:t>[13] </a:t>
             </a:r>
             <a:r>
               <a:rPr sz="850">
@@ -4154,13 +4154,13 @@
               </a:spcAft>
             </a:pPr>
             <a:r>
-              <a:rPr sz="850">
+              <a:rPr sz="850" b="1">
                 <a:solidFill>
                   <a:srgbClr val="76F3FB"/>
                 </a:solidFill>
                 <a:latin typeface="Calibri"/>
               </a:rPr>
-              <a:t>▸ </a:t>
+              <a:t>[14] </a:t>
             </a:r>
             <a:r>
               <a:rPr sz="850">
@@ -4182,13 +4182,13 @@
               </a:spcAft>
             </a:pPr>
             <a:r>
-              <a:rPr sz="850">
+              <a:rPr sz="850" b="1">
                 <a:solidFill>
                   <a:srgbClr val="76F3FB"/>
                 </a:solidFill>
                 <a:latin typeface="Calibri"/>
               </a:rPr>
-              <a:t>▸ </a:t>
+              <a:t>[15] </a:t>
             </a:r>
             <a:r>
               <a:rPr sz="850">
@@ -5265,7 +5265,7 @@
                 </a:solidFill>
                 <a:latin typeface="Calibri"/>
               </a:rPr>
-              <a:t>Modelele LLM (ChatGPT, GPT-4, Gemini) generează texte aproape indistinguibile de cele scrise de oameni.</a:t>
+              <a:t>Modelele LLM (ChatGPT, GPT-4, Gemini) generează texte aproape indistinguibile de cele scrise de oameni [2].</a:t>
             </a:r>
           </a:p>
           <a:p>
@@ -5349,7 +5349,7 @@
                 </a:solidFill>
                 <a:latin typeface="Calibri"/>
               </a:rPr>
-              <a:t>Impact real: site-uri de știri false AI ×10 în 2023 (49→600+); 64% se tem de manipularea alegerilor (KPMG 2025).</a:t>
+              <a:t>Impact real: site-uri de știri false AI ×10 în 2023 (49→600+) [12]; 64% se tem de manipularea alegerilor [6].</a:t>
             </a:r>
           </a:p>
         </p:txBody>
@@ -5527,7 +5527,7 @@
                 </a:solidFill>
                 <a:latin typeface="Calibri"/>
               </a:rPr>
-              <a:t>Metode statistice — perplexitate, entropie (GLTR)</a:t>
+              <a:t>Metode statistice — perplexitate, entropie (GLTR) [5]</a:t>
             </a:r>
           </a:p>
           <a:p>
@@ -5555,7 +5555,7 @@
                 </a:solidFill>
                 <a:latin typeface="Calibri"/>
               </a:rPr>
-              <a:t>Watermarking — semnal ascuns la generare</a:t>
+              <a:t>Watermarking — semnal ascuns la generare [8]</a:t>
             </a:r>
           </a:p>
           <a:p>
@@ -5583,7 +5583,7 @@
                 </a:solidFill>
                 <a:latin typeface="Calibri"/>
               </a:rPr>
-              <a:t>Clasificatori supervizați — RoBERTa fine-tuned</a:t>
+              <a:t>Clasificatori supervizați — RoBERTa fine-tuned [10]</a:t>
             </a:r>
           </a:p>
           <a:p>
@@ -5611,7 +5611,7 @@
                 </a:solidFill>
                 <a:latin typeface="Calibri"/>
               </a:rPr>
-              <a:t>Metode zero-shot — DetectGPT</a:t>
+              <a:t>Metode zero-shot — DetectGPT [11]</a:t>
             </a:r>
           </a:p>
         </p:txBody>
@@ -5694,7 +5694,7 @@
                 </a:solidFill>
                 <a:latin typeface="Calibri"/>
               </a:rPr>
-              <a:t>Limitare comună: toate sunt evaluate pe texte lungi și formale, iar parafrazarea reduce acuratețea de la &gt;90% la &lt;50%.</a:t>
+              <a:t>Limitare comună: toate sunt evaluate pe texte lungi și formale, iar parafrazarea reduce acuratețea de la &gt;90% la &lt;50% [9].</a:t>
             </a:r>
           </a:p>
         </p:txBody>
@@ -8904,7 +8904,7 @@
                 </a:solidFill>
                 <a:latin typeface="Calibri"/>
               </a:rPr>
-              <a:t>5 aplicații comerciale studiate (GPTZero, ZeroGPT, OpenAI Classifier, Originality.ai, Sapling) — toate slabe pe texte scurte.</a:t>
+              <a:t>5 aplicații comerciale studiate (GPTZero [14], ZeroGPT, OpenAI Classifier, Originality.ai, Sapling) — toate slabe pe texte scurte.</a:t>
             </a:r>
           </a:p>
         </p:txBody>
@@ -9114,7 +9114,7 @@
                 </a:solidFill>
                 <a:latin typeface="Calibri"/>
               </a:rPr>
-              <a:t>4 categorii identificate (statistice, watermarking, supervizate, zero-shot) și limitările lor.</a:t>
+              <a:t>4 categorii identificate (statistice [5], watermarking [8], supervizate, zero-shot [11]) și limitările lor [13].</a:t>
             </a:r>
           </a:p>
         </p:txBody>
@@ -10084,7 +10084,7 @@
                 </a:solidFill>
                 <a:latin typeface="Calibri"/>
               </a:rPr>
-              <a:t>RoBERTa fine-tuned (125M parametri) — model principal contextual.</a:t>
+              <a:t>RoBERTa fine-tuned (125M parametri) [10] — model principal, bazat pe Transformer [15].</a:t>
             </a:r>
           </a:p>
         </p:txBody>
@@ -10250,7 +10250,7 @@
                 </a:solidFill>
                 <a:latin typeface="Calibri"/>
               </a:rPr>
-              <a:t>● HC3 Reddit ELI5</a:t>
+              <a:t>● HC3 Reddit ELI5 [7]</a:t>
             </a:r>
           </a:p>
         </p:txBody>
@@ -10328,7 +10328,7 @@
                 </a:solidFill>
                 <a:latin typeface="Calibri"/>
               </a:rPr>
-              <a:t>● TweetEval</a:t>
+              <a:t>● TweetEval [1]</a:t>
             </a:r>
           </a:p>
         </p:txBody>
@@ -10484,7 +10484,7 @@
                 </a:solidFill>
                 <a:latin typeface="Calibri"/>
               </a:rPr>
-              <a:t>● RAID (2024)</a:t>
+              <a:t>● RAID (2024) [4]</a:t>
             </a:r>
           </a:p>
         </p:txBody>
@@ -11827,7 +11827,7 @@
                 </a:solidFill>
                 <a:latin typeface="Calibri"/>
               </a:rPr>
-              <a:t>Testat pe 6.876 exemple (50/50). Pe sursele propriu-zise de social media: acuratețe &gt;99.5%.</a:t>
+              <a:t>Testat pe 6.876 exemple (50/50). Pe sursele propriu-zise de social media: acuratețe &gt;99.5% — confirmă teoria detectabilității [3].</a:t>
             </a:r>
           </a:p>
         </p:txBody>

</xml_diff>